<commit_message>
Maintenance record. New filters. New tests
</commit_message>
<xml_diff>
--- a/Office_stuff/Tarpinio Gynimo skaidrės.pptx
+++ b/Office_stuff/Tarpinio Gynimo skaidrės.pptx
@@ -212,7 +212,7 @@
           <a:p>
             <a:fld id="{94D01F65-ADE3-4424-A0F2-5E1F648B8E51}" type="datetimeFigureOut">
               <a:rPr lang="en-US" smtClean="0"/>
-              <a:t>5/11/2026</a:t>
+              <a:t>5/12/2026</a:t>
             </a:fld>
             <a:endParaRPr lang="en-US"/>
           </a:p>
@@ -523,6 +523,90 @@
           <a:bodyPr/>
           <a:lstStyle/>
           <a:p>
+            <a:endParaRPr lang="en-GB" dirty="0"/>
+          </a:p>
+        </p:txBody>
+      </p:sp>
+      <p:sp>
+        <p:nvSpPr>
+          <p:cNvPr id="4" name="Slide Number Placeholder 3"/>
+          <p:cNvSpPr>
+            <a:spLocks noGrp="1"/>
+          </p:cNvSpPr>
+          <p:nvPr>
+            <p:ph type="sldNum" sz="quarter" idx="5"/>
+          </p:nvPr>
+        </p:nvSpPr>
+        <p:spPr/>
+        <p:txBody>
+          <a:bodyPr/>
+          <a:lstStyle/>
+          <a:p>
+            <a:fld id="{7D3D8D8B-2BC7-463E-BFD7-61670D39E088}" type="slidenum">
+              <a:rPr lang="en-US" smtClean="0"/>
+              <a:t>10</a:t>
+            </a:fld>
+            <a:endParaRPr lang="en-US"/>
+          </a:p>
+        </p:txBody>
+      </p:sp>
+    </p:spTree>
+    <p:extLst>
+      <p:ext uri="{BB962C8B-B14F-4D97-AF65-F5344CB8AC3E}">
+        <p14:creationId xmlns:p14="http://schemas.microsoft.com/office/powerpoint/2010/main" val="407739554"/>
+      </p:ext>
+    </p:extLst>
+  </p:cSld>
+  <p:clrMapOvr>
+    <a:masterClrMapping/>
+  </p:clrMapOvr>
+</p:notes>
+</file>
+
+<file path=ppt/notesSlides/notesSlide2.xml><?xml version="1.0" encoding="utf-8"?>
+<p:notes xmlns:a="http://schemas.openxmlformats.org/drawingml/2006/main" xmlns:r="http://schemas.openxmlformats.org/officeDocument/2006/relationships" xmlns:p="http://schemas.openxmlformats.org/presentationml/2006/main">
+  <p:cSld>
+    <p:spTree>
+      <p:nvGrpSpPr>
+        <p:cNvPr id="1" name=""/>
+        <p:cNvGrpSpPr/>
+        <p:nvPr/>
+      </p:nvGrpSpPr>
+      <p:grpSpPr>
+        <a:xfrm>
+          <a:off x="0" y="0"/>
+          <a:ext cx="0" cy="0"/>
+          <a:chOff x="0" y="0"/>
+          <a:chExt cx="0" cy="0"/>
+        </a:xfrm>
+      </p:grpSpPr>
+      <p:sp>
+        <p:nvSpPr>
+          <p:cNvPr id="2" name="Slide Image Placeholder 1"/>
+          <p:cNvSpPr>
+            <a:spLocks noGrp="1" noRot="1" noChangeAspect="1"/>
+          </p:cNvSpPr>
+          <p:nvPr>
+            <p:ph type="sldImg"/>
+          </p:nvPr>
+        </p:nvSpPr>
+        <p:spPr/>
+      </p:sp>
+      <p:sp>
+        <p:nvSpPr>
+          <p:cNvPr id="3" name="Notes Placeholder 2"/>
+          <p:cNvSpPr>
+            <a:spLocks noGrp="1"/>
+          </p:cNvSpPr>
+          <p:nvPr>
+            <p:ph type="body" idx="1"/>
+          </p:nvPr>
+        </p:nvSpPr>
+        <p:spPr/>
+        <p:txBody>
+          <a:bodyPr/>
+          <a:lstStyle/>
+          <a:p>
             <a:endParaRPr lang="en-US" dirty="0"/>
           </a:p>
         </p:txBody>
@@ -563,7 +647,7 @@
 </p:notes>
 </file>
 
-<file path=ppt/notesSlides/notesSlide2.xml><?xml version="1.0" encoding="utf-8"?>
+<file path=ppt/notesSlides/notesSlide3.xml><?xml version="1.0" encoding="utf-8"?>
 <p:notes xmlns:a="http://schemas.openxmlformats.org/drawingml/2006/main" xmlns:r="http://schemas.openxmlformats.org/officeDocument/2006/relationships" xmlns:p="http://schemas.openxmlformats.org/presentationml/2006/main">
   <p:cSld>
     <p:spTree>
@@ -671,7 +755,7 @@
 </p:notes>
 </file>
 
-<file path=ppt/notesSlides/notesSlide3.xml><?xml version="1.0" encoding="utf-8"?>
+<file path=ppt/notesSlides/notesSlide4.xml><?xml version="1.0" encoding="utf-8"?>
 <p:notes xmlns:a="http://schemas.openxmlformats.org/drawingml/2006/main" xmlns:r="http://schemas.openxmlformats.org/officeDocument/2006/relationships" xmlns:p="http://schemas.openxmlformats.org/presentationml/2006/main">
   <p:cSld>
     <p:spTree>
@@ -779,7 +863,7 @@
 </p:notes>
 </file>
 
-<file path=ppt/notesSlides/notesSlide4.xml><?xml version="1.0" encoding="utf-8"?>
+<file path=ppt/notesSlides/notesSlide5.xml><?xml version="1.0" encoding="utf-8"?>
 <p:notes xmlns:a="http://schemas.openxmlformats.org/drawingml/2006/main" xmlns:r="http://schemas.openxmlformats.org/officeDocument/2006/relationships" xmlns:p="http://schemas.openxmlformats.org/presentationml/2006/main">
   <p:cSld>
     <p:spTree>
@@ -887,7 +971,7 @@
 </p:notes>
 </file>
 
-<file path=ppt/notesSlides/notesSlide5.xml><?xml version="1.0" encoding="utf-8"?>
+<file path=ppt/notesSlides/notesSlide6.xml><?xml version="1.0" encoding="utf-8"?>
 <p:notes xmlns:a="http://schemas.openxmlformats.org/drawingml/2006/main" xmlns:r="http://schemas.openxmlformats.org/officeDocument/2006/relationships" xmlns:p="http://schemas.openxmlformats.org/presentationml/2006/main">
   <p:cSld>
     <p:spTree>
@@ -1126,7 +1210,7 @@
           <a:p>
             <a:fld id="{74F880E5-5F82-415C-9525-1F3631A7AE8F}" type="datetime1">
               <a:rPr lang="en-US" smtClean="0"/>
-              <a:t>5/11/2026</a:t>
+              <a:t>5/12/2026</a:t>
             </a:fld>
             <a:endParaRPr lang="en-US"/>
           </a:p>
@@ -1296,7 +1380,7 @@
           <a:p>
             <a:fld id="{63287B1D-AF4C-43BA-A2CC-3D3995A8E269}" type="datetime1">
               <a:rPr lang="en-US" smtClean="0"/>
-              <a:t>5/11/2026</a:t>
+              <a:t>5/12/2026</a:t>
             </a:fld>
             <a:endParaRPr lang="en-US"/>
           </a:p>
@@ -1476,7 +1560,7 @@
           <a:p>
             <a:fld id="{1EA15F11-500F-40CB-A231-56DAC8067F9F}" type="datetime1">
               <a:rPr lang="en-US" smtClean="0"/>
-              <a:t>5/11/2026</a:t>
+              <a:t>5/12/2026</a:t>
             </a:fld>
             <a:endParaRPr lang="en-US"/>
           </a:p>
@@ -1646,7 +1730,7 @@
           <a:p>
             <a:fld id="{7ED0485C-C0C8-49F5-A85A-1480642569F2}" type="datetime1">
               <a:rPr lang="en-US" smtClean="0"/>
-              <a:t>5/11/2026</a:t>
+              <a:t>5/12/2026</a:t>
             </a:fld>
             <a:endParaRPr lang="en-US"/>
           </a:p>
@@ -1892,7 +1976,7 @@
           <a:p>
             <a:fld id="{AFCA74A8-EEE6-4E2C-969F-BCCD7B351E6C}" type="datetime1">
               <a:rPr lang="en-US" smtClean="0"/>
-              <a:t>5/11/2026</a:t>
+              <a:t>5/12/2026</a:t>
             </a:fld>
             <a:endParaRPr lang="en-US"/>
           </a:p>
@@ -2124,7 +2208,7 @@
           <a:p>
             <a:fld id="{9E6162BC-34BB-45B1-BF1A-3FB9ED2801EB}" type="datetime1">
               <a:rPr lang="en-US" smtClean="0"/>
-              <a:t>5/11/2026</a:t>
+              <a:t>5/12/2026</a:t>
             </a:fld>
             <a:endParaRPr lang="en-US"/>
           </a:p>
@@ -2491,7 +2575,7 @@
           <a:p>
             <a:fld id="{60B5E9F1-B21A-41A2-B2F0-56E2FDED885B}" type="datetime1">
               <a:rPr lang="en-US" smtClean="0"/>
-              <a:t>5/11/2026</a:t>
+              <a:t>5/12/2026</a:t>
             </a:fld>
             <a:endParaRPr lang="en-US"/>
           </a:p>
@@ -2609,7 +2693,7 @@
           <a:p>
             <a:fld id="{F1579879-1CA8-4A23-B24B-EC9F3C303221}" type="datetime1">
               <a:rPr lang="en-US" smtClean="0"/>
-              <a:t>5/11/2026</a:t>
+              <a:t>5/12/2026</a:t>
             </a:fld>
             <a:endParaRPr lang="en-US"/>
           </a:p>
@@ -2704,7 +2788,7 @@
           <a:p>
             <a:fld id="{16B6C98E-CCA0-4AF2-8099-7186DF10A5E7}" type="datetime1">
               <a:rPr lang="en-US" smtClean="0"/>
-              <a:t>5/11/2026</a:t>
+              <a:t>5/12/2026</a:t>
             </a:fld>
             <a:endParaRPr lang="en-US"/>
           </a:p>
@@ -2981,7 +3065,7 @@
           <a:p>
             <a:fld id="{BED2C339-A0F1-478A-AFF9-60088043FEBD}" type="datetime1">
               <a:rPr lang="en-US" smtClean="0"/>
-              <a:t>5/11/2026</a:t>
+              <a:t>5/12/2026</a:t>
             </a:fld>
             <a:endParaRPr lang="en-US"/>
           </a:p>
@@ -3238,7 +3322,7 @@
           <a:p>
             <a:fld id="{8DB4C5FF-1ED0-424D-BFE3-4CED3A90D626}" type="datetime1">
               <a:rPr lang="en-US" smtClean="0"/>
-              <a:t>5/11/2026</a:t>
+              <a:t>5/12/2026</a:t>
             </a:fld>
             <a:endParaRPr lang="en-US"/>
           </a:p>
@@ -3451,7 +3535,7 @@
           <a:p>
             <a:fld id="{9190BF23-92F6-4A4D-B279-6F5D5BFDB7CE}" type="datetime1">
               <a:rPr lang="en-US" smtClean="0"/>
-              <a:t>5/11/2026</a:t>
+              <a:t>5/12/2026</a:t>
             </a:fld>
             <a:endParaRPr lang="en-US"/>
           </a:p>
@@ -4151,7 +4235,7 @@
     <p:bg>
       <p:bgPr>
         <a:blipFill dpi="0" rotWithShape="1">
-          <a:blip r:embed="rId2">
+          <a:blip r:embed="rId3">
             <a:lum/>
           </a:blip>
           <a:srcRect/>
@@ -4270,7 +4354,7 @@
           <p:nvPr/>
         </p:nvPicPr>
         <p:blipFill>
-          <a:blip r:embed="rId3"/>
+          <a:blip r:embed="rId4"/>
           <a:stretch>
             <a:fillRect/>
           </a:stretch>
@@ -4395,7 +4479,12 @@
             <p:ph type="sldNum" sz="quarter" idx="12"/>
           </p:nvPr>
         </p:nvSpPr>
-        <p:spPr/>
+        <p:spPr>
+          <a:xfrm>
+            <a:off x="15067429" y="1229735"/>
+            <a:ext cx="5486043" cy="730250"/>
+          </a:xfrm>
+        </p:spPr>
         <p:txBody>
           <a:bodyPr/>
           <a:lstStyle/>
@@ -4409,10 +4498,10 @@
       </p:sp>
       <p:pic>
         <p:nvPicPr>
-          <p:cNvPr id="6" name="Picture 5">
+          <p:cNvPr id="8" name="Picture 7">
             <a:extLst>
               <a:ext uri="{FF2B5EF4-FFF2-40B4-BE49-F238E27FC236}">
-                <a16:creationId xmlns:a16="http://schemas.microsoft.com/office/drawing/2014/main" id="{1EE2F712-A7DB-3D77-D13C-C1D6CEC5ACE8}"/>
+                <a16:creationId xmlns:a16="http://schemas.microsoft.com/office/drawing/2014/main" id="{93B74C95-9427-86CD-8C10-E2F30E2A782C}"/>
               </a:ext>
             </a:extLst>
           </p:cNvPr>
@@ -4429,38 +4518,8 @@
         </p:blipFill>
         <p:spPr>
           <a:xfrm>
-            <a:off x="152918" y="2936496"/>
-            <a:ext cx="14018831" cy="10506455"/>
-          </a:xfrm>
-          <a:prstGeom prst="rect">
-            <a:avLst/>
-          </a:prstGeom>
-        </p:spPr>
-      </p:pic>
-      <p:pic>
-        <p:nvPicPr>
-          <p:cNvPr id="7" name="Picture 6">
-            <a:extLst>
-              <a:ext uri="{FF2B5EF4-FFF2-40B4-BE49-F238E27FC236}">
-                <a16:creationId xmlns:a16="http://schemas.microsoft.com/office/drawing/2014/main" id="{24826011-4B50-D999-D662-17887662F54B}"/>
-              </a:ext>
-            </a:extLst>
-          </p:cNvPr>
-          <p:cNvPicPr>
-            <a:picLocks noChangeAspect="1"/>
-          </p:cNvPicPr>
-          <p:nvPr/>
-        </p:nvPicPr>
-        <p:blipFill>
-          <a:blip r:embed="rId4"/>
-          <a:stretch>
-            <a:fillRect/>
-          </a:stretch>
-        </p:blipFill>
-        <p:spPr>
-          <a:xfrm>
-            <a:off x="14146131" y="6580882"/>
-            <a:ext cx="9824305" cy="4198622"/>
+            <a:off x="1676290" y="2175553"/>
+            <a:ext cx="21029831" cy="11411536"/>
           </a:xfrm>
           <a:prstGeom prst="rect">
             <a:avLst/>
@@ -4696,12 +4755,45 @@
           </a:p>
         </p:txBody>
       </p:sp>
+      <p:sp>
+        <p:nvSpPr>
+          <p:cNvPr id="2" name="Slide Number Placeholder 1">
+            <a:extLst>
+              <a:ext uri="{FF2B5EF4-FFF2-40B4-BE49-F238E27FC236}">
+                <a16:creationId xmlns:a16="http://schemas.microsoft.com/office/drawing/2014/main" id="{E797DF00-D812-3E5E-C0D4-B596949781D4}"/>
+              </a:ext>
+            </a:extLst>
+          </p:cNvPr>
+          <p:cNvSpPr>
+            <a:spLocks noGrp="1"/>
+          </p:cNvSpPr>
+          <p:nvPr>
+            <p:ph type="sldNum" sz="quarter" idx="12"/>
+          </p:nvPr>
+        </p:nvSpPr>
+        <p:spPr>
+          <a:xfrm>
+            <a:off x="15183498" y="1229735"/>
+            <a:ext cx="5486043" cy="730250"/>
+          </a:xfrm>
+        </p:spPr>
+        <p:txBody>
+          <a:bodyPr/>
+          <a:lstStyle/>
+          <a:p>
+            <a:r>
+              <a:rPr lang="lt-LT" sz="3600" dirty="0"/>
+              <a:t>12</a:t>
+            </a:r>
+          </a:p>
+        </p:txBody>
+      </p:sp>
       <p:pic>
         <p:nvPicPr>
-          <p:cNvPr id="6" name="Picture 5">
+          <p:cNvPr id="10" name="Picture 9">
             <a:extLst>
               <a:ext uri="{FF2B5EF4-FFF2-40B4-BE49-F238E27FC236}">
-                <a16:creationId xmlns:a16="http://schemas.microsoft.com/office/drawing/2014/main" id="{1E5917BD-3993-302D-9834-50EF361604C4}"/>
+                <a16:creationId xmlns:a16="http://schemas.microsoft.com/office/drawing/2014/main" id="{74E003CF-1784-D1FA-4E4E-C208B0D26723}"/>
               </a:ext>
             </a:extLst>
           </p:cNvPr>
@@ -4718,42 +4810,14 @@
         </p:blipFill>
         <p:spPr>
           <a:xfrm>
-            <a:off x="1189754" y="2920424"/>
-            <a:ext cx="23261014" cy="10283512"/>
+            <a:off x="680887" y="3200400"/>
+            <a:ext cx="23020637" cy="10515600"/>
           </a:xfrm>
           <a:prstGeom prst="rect">
             <a:avLst/>
           </a:prstGeom>
         </p:spPr>
       </p:pic>
-      <p:sp>
-        <p:nvSpPr>
-          <p:cNvPr id="2" name="Slide Number Placeholder 1">
-            <a:extLst>
-              <a:ext uri="{FF2B5EF4-FFF2-40B4-BE49-F238E27FC236}">
-                <a16:creationId xmlns:a16="http://schemas.microsoft.com/office/drawing/2014/main" id="{E797DF00-D812-3E5E-C0D4-B596949781D4}"/>
-              </a:ext>
-            </a:extLst>
-          </p:cNvPr>
-          <p:cNvSpPr>
-            <a:spLocks noGrp="1"/>
-          </p:cNvSpPr>
-          <p:nvPr>
-            <p:ph type="sldNum" sz="quarter" idx="12"/>
-          </p:nvPr>
-        </p:nvSpPr>
-        <p:spPr/>
-        <p:txBody>
-          <a:bodyPr/>
-          <a:lstStyle/>
-          <a:p>
-            <a:r>
-              <a:rPr lang="lt-LT" sz="3600" dirty="0"/>
-              <a:t>12</a:t>
-            </a:r>
-          </a:p>
-        </p:txBody>
-      </p:sp>
     </p:spTree>
     <p:extLst>
       <p:ext uri="{BB962C8B-B14F-4D97-AF65-F5344CB8AC3E}">
@@ -5030,7 +5094,11 @@
           <a:p>
             <a:r>
               <a:rPr lang="lt-LT" noProof="0" dirty="0"/>
-              <a:t>Testų kiekis – 256</a:t>
+              <a:t>Testų kiekis – 2</a:t>
+            </a:r>
+            <a:r>
+              <a:rPr lang="lt-LT" dirty="0"/>
+              <a:t>83</a:t>
             </a:r>
           </a:p>
           <a:p>
@@ -5162,7 +5230,7 @@
                 <a:latin typeface="Times New Roman" panose="02020603050405020304" pitchFamily="18" charset="0"/>
                 <a:ea typeface="Calibri" panose="020F0502020204030204" pitchFamily="34" charset="0"/>
               </a:rPr>
-              <a:t>90,5</a:t>
+              <a:t>91</a:t>
             </a:r>
             <a:r>
               <a:rPr lang="lt-LT" sz="3600" noProof="0" dirty="0">
@@ -5180,7 +5248,22 @@
                 <a:latin typeface="Times New Roman" panose="02020603050405020304" pitchFamily="18" charset="0"/>
                 <a:ea typeface="Calibri" panose="020F0502020204030204" pitchFamily="34" charset="0"/>
               </a:rPr>
-              <a:t>Padengta – 75,7% serverio dalies eilučių</a:t>
+              <a:t>Padengta – 7</a:t>
+            </a:r>
+            <a:r>
+              <a:rPr lang="lt-LT" dirty="0">
+                <a:latin typeface="Times New Roman" panose="02020603050405020304" pitchFamily="18" charset="0"/>
+                <a:ea typeface="Calibri" panose="020F0502020204030204" pitchFamily="34" charset="0"/>
+              </a:rPr>
+              <a:t>7,9</a:t>
+            </a:r>
+            <a:r>
+              <a:rPr lang="lt-LT" sz="3600" noProof="0" dirty="0">
+                <a:effectLst/>
+                <a:latin typeface="Times New Roman" panose="02020603050405020304" pitchFamily="18" charset="0"/>
+                <a:ea typeface="Calibri" panose="020F0502020204030204" pitchFamily="34" charset="0"/>
+              </a:rPr>
+              <a:t>% serverio dalies eilučių</a:t>
             </a:r>
           </a:p>
         </p:txBody>
@@ -5894,14 +5977,14 @@
           <p:nvPr>
             <p:extLst>
               <p:ext uri="{D42A27DB-BD31-4B8C-83A1-F6EECF244321}">
-                <p14:modId xmlns:p14="http://schemas.microsoft.com/office/powerpoint/2010/main" val="1834960494"/>
+                <p14:modId xmlns:p14="http://schemas.microsoft.com/office/powerpoint/2010/main" val="18920443"/>
               </p:ext>
             </p:extLst>
           </p:nvPr>
         </p:nvGraphicFramePr>
         <p:xfrm>
           <a:off x="671664" y="4773168"/>
-          <a:ext cx="23039084" cy="5952744"/>
+          <a:ext cx="23039084" cy="6803136"/>
         </p:xfrm>
         <a:graphic>
           <a:graphicData uri="http://schemas.openxmlformats.org/drawingml/2006/table">
@@ -5990,7 +6073,7 @@
                           <a:ea typeface="+mn-ea"/>
                           <a:cs typeface="+mn-cs"/>
                         </a:rPr>
-                        <a:t>Olio</a:t>
+                        <a:t>Stuffly</a:t>
                       </a:r>
                       <a:endParaRPr lang="lt-LT" dirty="0"/>
                     </a:p>
@@ -6013,152 +6096,6 @@
                 <a:extLst>
                   <a:ext uri="{0D108BD9-81ED-4DB2-BD59-A6C34878D82A}">
                     <a16:rowId xmlns:a16="http://schemas.microsoft.com/office/drawing/2014/main" val="2872177194"/>
-                  </a:ext>
-                </a:extLst>
-              </a:tr>
-              <a:tr h="850392">
-                <a:tc>
-                  <a:txBody>
-                    <a:bodyPr/>
-                    <a:lstStyle/>
-                    <a:p>
-                      <a:r>
-                        <a:rPr lang="lt-LT" sz="3600" kern="1200" dirty="0">
-                          <a:solidFill>
-                            <a:schemeClr val="dk1"/>
-                          </a:solidFill>
-                          <a:effectLst/>
-                          <a:latin typeface="+mn-lt"/>
-                          <a:ea typeface="+mn-ea"/>
-                          <a:cs typeface="+mn-cs"/>
-                        </a:rPr>
-                        <a:t>Prekių apmokestinimas</a:t>
-                      </a:r>
-                      <a:endParaRPr lang="lt-LT" dirty="0"/>
-                    </a:p>
-                  </a:txBody>
-                  <a:tcPr/>
-                </a:tc>
-                <a:tc>
-                  <a:txBody>
-                    <a:bodyPr/>
-                    <a:lstStyle/>
-                    <a:p>
-                      <a:pPr marL="0" algn="l" defTabSz="1828709" rtl="0" eaLnBrk="1" latinLnBrk="0" hangingPunct="1">
-                        <a:spcBef>
-                          <a:spcPts val="300"/>
-                        </a:spcBef>
-                        <a:spcAft>
-                          <a:spcPts val="300"/>
-                        </a:spcAft>
-                        <a:buNone/>
-                      </a:pPr>
-                      <a:r>
-                        <a:rPr lang="lt-LT" sz="3600" kern="1200" dirty="0">
-                          <a:solidFill>
-                            <a:schemeClr val="dk1"/>
-                          </a:solidFill>
-                          <a:effectLst/>
-                          <a:latin typeface="+mn-lt"/>
-                          <a:ea typeface="+mn-ea"/>
-                          <a:cs typeface="+mn-cs"/>
-                        </a:rPr>
-                        <a:t>Galimas</a:t>
-                      </a:r>
-                      <a:endParaRPr lang="en-GB" sz="3600" kern="1200" dirty="0">
-                        <a:solidFill>
-                          <a:schemeClr val="dk1"/>
-                        </a:solidFill>
-                        <a:effectLst/>
-                        <a:latin typeface="+mn-lt"/>
-                        <a:ea typeface="+mn-ea"/>
-                        <a:cs typeface="+mn-cs"/>
-                      </a:endParaRPr>
-                    </a:p>
-                  </a:txBody>
-                  <a:tcPr marL="68580" marR="68580" marT="0" marB="0"/>
-                </a:tc>
-                <a:tc>
-                  <a:txBody>
-                    <a:bodyPr/>
-                    <a:lstStyle/>
-                    <a:p>
-                      <a:pPr marL="0" algn="l" defTabSz="1828709" rtl="0" eaLnBrk="1" latinLnBrk="0" hangingPunct="1">
-                        <a:spcBef>
-                          <a:spcPts val="300"/>
-                        </a:spcBef>
-                        <a:spcAft>
-                          <a:spcPts val="300"/>
-                        </a:spcAft>
-                        <a:buNone/>
-                      </a:pPr>
-                      <a:r>
-                        <a:rPr lang="lt-LT" sz="3600" kern="1200">
-                          <a:solidFill>
-                            <a:schemeClr val="dk1"/>
-                          </a:solidFill>
-                          <a:effectLst/>
-                          <a:latin typeface="+mn-lt"/>
-                          <a:ea typeface="+mn-ea"/>
-                          <a:cs typeface="+mn-cs"/>
-                        </a:rPr>
-                        <a:t>Galimas</a:t>
-                      </a:r>
-                      <a:endParaRPr lang="en-GB" sz="3600" kern="1200">
-                        <a:solidFill>
-                          <a:schemeClr val="dk1"/>
-                        </a:solidFill>
-                        <a:effectLst/>
-                        <a:latin typeface="+mn-lt"/>
-                        <a:ea typeface="+mn-ea"/>
-                        <a:cs typeface="+mn-cs"/>
-                      </a:endParaRPr>
-                    </a:p>
-                  </a:txBody>
-                  <a:tcPr marL="68580" marR="68580" marT="0" marB="0"/>
-                </a:tc>
-                <a:tc>
-                  <a:txBody>
-                    <a:bodyPr/>
-                    <a:lstStyle/>
-                    <a:p>
-                      <a:pPr marL="0" algn="l" defTabSz="1828709" rtl="0" eaLnBrk="1" latinLnBrk="0" hangingPunct="1">
-                        <a:spcBef>
-                          <a:spcPts val="300"/>
-                        </a:spcBef>
-                        <a:spcAft>
-                          <a:spcPts val="300"/>
-                        </a:spcAft>
-                        <a:buNone/>
-                      </a:pPr>
-                      <a:r>
-                        <a:rPr lang="lt-LT" sz="3600" kern="1200">
-                          <a:solidFill>
-                            <a:schemeClr val="dk1"/>
-                          </a:solidFill>
-                          <a:effectLst/>
-                          <a:latin typeface="+mn-lt"/>
-                          <a:ea typeface="+mn-ea"/>
-                          <a:cs typeface="+mn-cs"/>
-                        </a:rPr>
-                        <a:t>Nėra</a:t>
-                      </a:r>
-                      <a:endParaRPr lang="en-GB" sz="3600" kern="1200">
-                        <a:solidFill>
-                          <a:schemeClr val="dk1"/>
-                        </a:solidFill>
-                        <a:effectLst/>
-                        <a:latin typeface="+mn-lt"/>
-                        <a:ea typeface="+mn-ea"/>
-                        <a:cs typeface="+mn-cs"/>
-                      </a:endParaRPr>
-                    </a:p>
-                  </a:txBody>
-                  <a:tcPr marL="68580" marR="68580" marT="0" marB="0"/>
-                </a:tc>
-                <a:extLst>
-                  <a:ext uri="{0D108BD9-81ED-4DB2-BD59-A6C34878D82A}">
-                    <a16:rowId xmlns:a16="http://schemas.microsoft.com/office/drawing/2014/main" val="1943936857"/>
                   </a:ext>
                 </a:extLst>
               </a:tr>
@@ -6346,7 +6283,7 @@
                         <a:buNone/>
                       </a:pPr>
                       <a:r>
-                        <a:rPr lang="en-US" sz="3600" kern="1200">
+                        <a:rPr lang="en-US" sz="3600" kern="1200" dirty="0">
                           <a:solidFill>
                             <a:schemeClr val="dk1"/>
                           </a:solidFill>
@@ -6355,9 +6292,21 @@
                           <a:ea typeface="+mn-ea"/>
                           <a:cs typeface="+mn-cs"/>
                         </a:rPr>
-                        <a:t>Olandų, Anglų</a:t>
+                        <a:t>Olandų, </a:t>
                       </a:r>
-                      <a:endParaRPr lang="en-GB" sz="3600" kern="1200">
+                      <a:r>
+                        <a:rPr lang="en-US" sz="3600" kern="1200" dirty="0" err="1">
+                          <a:solidFill>
+                            <a:schemeClr val="dk1"/>
+                          </a:solidFill>
+                          <a:effectLst/>
+                          <a:latin typeface="+mn-lt"/>
+                          <a:ea typeface="+mn-ea"/>
+                          <a:cs typeface="+mn-cs"/>
+                        </a:rPr>
+                        <a:t>Anglų</a:t>
+                      </a:r>
+                      <a:endParaRPr lang="en-GB" sz="3600" kern="1200" dirty="0">
                         <a:solidFill>
                           <a:schemeClr val="dk1"/>
                         </a:solidFill>
@@ -6540,7 +6489,7 @@
                           <a:ea typeface="+mn-ea"/>
                           <a:cs typeface="+mn-cs"/>
                         </a:rPr>
-                        <a:t>Nėra</a:t>
+                        <a:t>Rezervavimas kalendoriuje</a:t>
                       </a:r>
                       <a:endParaRPr lang="en-GB" sz="3600" kern="1200" dirty="0">
                         <a:solidFill>
@@ -6686,7 +6635,7 @@
                           <a:ea typeface="+mn-ea"/>
                           <a:cs typeface="+mn-cs"/>
                         </a:rPr>
-                        <a:t>Maistas/ne maistas</a:t>
+                        <a:t>Platus pasirinkimas</a:t>
                       </a:r>
                       <a:endParaRPr lang="en-GB" sz="3600" kern="1200" dirty="0">
                         <a:solidFill>
@@ -6753,6 +6702,28 @@
                     <a:lstStyle/>
                     <a:p>
                       <a:r>
+                        <a:rPr lang="lt-LT" dirty="0"/>
+                        <a:t>Paplitimas</a:t>
+                      </a:r>
+                    </a:p>
+                  </a:txBody>
+                  <a:tcPr/>
+                </a:tc>
+                <a:tc>
+                  <a:txBody>
+                    <a:bodyPr/>
+                    <a:lstStyle/>
+                    <a:p>
+                      <a:pPr marL="0" algn="l" defTabSz="1828709" rtl="0" eaLnBrk="1" latinLnBrk="0" hangingPunct="1">
+                        <a:spcBef>
+                          <a:spcPts val="300"/>
+                        </a:spcBef>
+                        <a:spcAft>
+                          <a:spcPts val="300"/>
+                        </a:spcAft>
+                        <a:buNone/>
+                      </a:pPr>
+                      <a:r>
                         <a:rPr lang="lt-LT" sz="3600" kern="1200" dirty="0">
                           <a:solidFill>
                             <a:schemeClr val="dk1"/>
@@ -6762,12 +6733,157 @@
                           <a:ea typeface="+mn-ea"/>
                           <a:cs typeface="+mn-cs"/>
                         </a:rPr>
-                        <a:t>Nemokamas atidavimas</a:t>
+                        <a:t>Olandija, Belgija</a:t>
                       </a:r>
-                      <a:endParaRPr lang="lt-LT" dirty="0"/>
+                      <a:endParaRPr lang="en-GB" sz="3600" kern="1200" dirty="0">
+                        <a:solidFill>
+                          <a:schemeClr val="dk1"/>
+                        </a:solidFill>
+                        <a:effectLst/>
+                        <a:latin typeface="+mn-lt"/>
+                        <a:ea typeface="+mn-ea"/>
+                        <a:cs typeface="+mn-cs"/>
+                      </a:endParaRPr>
+                    </a:p>
+                  </a:txBody>
+                  <a:tcPr marL="68580" marR="68580" marT="0" marB="0"/>
+                </a:tc>
+                <a:tc>
+                  <a:txBody>
+                    <a:bodyPr/>
+                    <a:lstStyle/>
+                    <a:p>
+                      <a:pPr marL="0" algn="l" defTabSz="1828709" rtl="0" eaLnBrk="1" latinLnBrk="0" hangingPunct="1">
+                        <a:spcBef>
+                          <a:spcPts val="300"/>
+                        </a:spcBef>
+                        <a:spcAft>
+                          <a:spcPts val="300"/>
+                        </a:spcAft>
+                        <a:buNone/>
+                      </a:pPr>
+                      <a:r>
+                        <a:rPr lang="lt-LT" sz="3600" kern="1200" dirty="0">
+                          <a:solidFill>
+                            <a:schemeClr val="dk1"/>
+                          </a:solidFill>
+                          <a:effectLst/>
+                          <a:latin typeface="+mn-lt"/>
+                          <a:ea typeface="+mn-ea"/>
+                          <a:cs typeface="+mn-cs"/>
+                        </a:rPr>
+                        <a:t>Belgija, Vokietija</a:t>
+                      </a:r>
+                      <a:endParaRPr lang="en-GB" sz="3600" kern="1200" dirty="0">
+                        <a:solidFill>
+                          <a:schemeClr val="dk1"/>
+                        </a:solidFill>
+                        <a:effectLst/>
+                        <a:latin typeface="+mn-lt"/>
+                        <a:ea typeface="+mn-ea"/>
+                        <a:cs typeface="+mn-cs"/>
+                      </a:endParaRPr>
+                    </a:p>
+                  </a:txBody>
+                  <a:tcPr marL="68580" marR="68580" marT="0" marB="0"/>
+                </a:tc>
+                <a:tc>
+                  <a:txBody>
+                    <a:bodyPr/>
+                    <a:lstStyle/>
+                    <a:p>
+                      <a:pPr marL="0" algn="l" defTabSz="1828709" rtl="0" eaLnBrk="1" latinLnBrk="0" hangingPunct="1">
+                        <a:spcBef>
+                          <a:spcPts val="300"/>
+                        </a:spcBef>
+                        <a:spcAft>
+                          <a:spcPts val="300"/>
+                        </a:spcAft>
+                        <a:buNone/>
+                      </a:pPr>
+                      <a:r>
+                        <a:rPr lang="lt-LT" sz="3600" kern="1200" dirty="0">
+                          <a:solidFill>
+                            <a:schemeClr val="dk1"/>
+                          </a:solidFill>
+                          <a:effectLst/>
+                          <a:latin typeface="+mn-lt"/>
+                          <a:ea typeface="+mn-ea"/>
+                          <a:cs typeface="+mn-cs"/>
+                        </a:rPr>
+                        <a:t>Lietuva</a:t>
+                      </a:r>
+                      <a:endParaRPr lang="en-GB" sz="3600" kern="1200" dirty="0">
+                        <a:solidFill>
+                          <a:schemeClr val="dk1"/>
+                        </a:solidFill>
+                        <a:effectLst/>
+                        <a:latin typeface="+mn-lt"/>
+                        <a:ea typeface="+mn-ea"/>
+                        <a:cs typeface="+mn-cs"/>
+                      </a:endParaRPr>
+                    </a:p>
+                  </a:txBody>
+                  <a:tcPr marL="68580" marR="68580" marT="0" marB="0"/>
+                </a:tc>
+                <a:extLst>
+                  <a:ext uri="{0D108BD9-81ED-4DB2-BD59-A6C34878D82A}">
+                    <a16:rowId xmlns:a16="http://schemas.microsoft.com/office/drawing/2014/main" val="1720776639"/>
+                  </a:ext>
+                </a:extLst>
+              </a:tr>
+              <a:tr h="850392">
+                <a:tc>
+                  <a:txBody>
+                    <a:bodyPr/>
+                    <a:lstStyle/>
+                    <a:p>
+                      <a:r>
+                        <a:rPr lang="lt-LT" dirty="0"/>
+                        <a:t>Daiktas žemėlapyje</a:t>
+                      </a:r>
                     </a:p>
                   </a:txBody>
                   <a:tcPr/>
+                </a:tc>
+                <a:tc>
+                  <a:txBody>
+                    <a:bodyPr/>
+                    <a:lstStyle/>
+                    <a:p>
+                      <a:pPr marL="0" algn="l" defTabSz="1828709" rtl="0" eaLnBrk="1" latinLnBrk="0" hangingPunct="1">
+                        <a:spcBef>
+                          <a:spcPts val="300"/>
+                        </a:spcBef>
+                        <a:spcAft>
+                          <a:spcPts val="300"/>
+                        </a:spcAft>
+                        <a:buNone/>
+                      </a:pPr>
+                      <a:r>
+                        <a:rPr lang="lt-LT" sz="3600" kern="1200" dirty="0">
+                          <a:solidFill>
+                            <a:schemeClr val="dk1"/>
+                          </a:solidFill>
+                          <a:effectLst/>
+                          <a:latin typeface="+mn-lt"/>
+                          <a:ea typeface="+mn-ea"/>
+                          <a:cs typeface="+mn-cs"/>
+                        </a:rPr>
+                        <a:t>Apytikslė vieta</a:t>
+                      </a:r>
+                      <a:endParaRPr lang="en-GB" sz="3600" kern="1200" dirty="0">
+                        <a:solidFill>
+                          <a:schemeClr val="dk1"/>
+                        </a:solidFill>
+                        <a:effectLst/>
+                        <a:latin typeface="+mn-lt"/>
+                        <a:ea typeface="+mn-ea"/>
+                        <a:cs typeface="+mn-cs"/>
+                      </a:endParaRPr>
+                    </a:p>
+                  </a:txBody>
+                  <a:tcPr marL="68580" marR="68580" marT="0" marB="0"/>
                 </a:tc>
                 <a:tc>
                   <a:txBody>
@@ -6832,7 +6948,66 @@
                           <a:ea typeface="+mn-ea"/>
                           <a:cs typeface="+mn-cs"/>
                         </a:rPr>
-                        <a:t>Yra </a:t>
+                        <a:t>Tikslus adresas</a:t>
+                      </a:r>
+                      <a:endParaRPr lang="en-GB" sz="3600" kern="1200" dirty="0">
+                        <a:solidFill>
+                          <a:schemeClr val="dk1"/>
+                        </a:solidFill>
+                        <a:effectLst/>
+                        <a:latin typeface="+mn-lt"/>
+                        <a:ea typeface="+mn-ea"/>
+                        <a:cs typeface="+mn-cs"/>
+                      </a:endParaRPr>
+                    </a:p>
+                  </a:txBody>
+                  <a:tcPr marL="68580" marR="68580" marT="0" marB="0"/>
+                </a:tc>
+                <a:extLst>
+                  <a:ext uri="{0D108BD9-81ED-4DB2-BD59-A6C34878D82A}">
+                    <a16:rowId xmlns:a16="http://schemas.microsoft.com/office/drawing/2014/main" val="1149401783"/>
+                  </a:ext>
+                </a:extLst>
+              </a:tr>
+              <a:tr h="850392">
+                <a:tc>
+                  <a:txBody>
+                    <a:bodyPr/>
+                    <a:lstStyle/>
+                    <a:p>
+                      <a:r>
+                        <a:rPr lang="lt-LT" dirty="0"/>
+                        <a:t>Auditorija</a:t>
+                      </a:r>
+                    </a:p>
+                  </a:txBody>
+                  <a:tcPr/>
+                </a:tc>
+                <a:tc>
+                  <a:txBody>
+                    <a:bodyPr/>
+                    <a:lstStyle/>
+                    <a:p>
+                      <a:pPr marL="0" algn="l" defTabSz="1828709" rtl="0" eaLnBrk="1" latinLnBrk="0" hangingPunct="1">
+                        <a:spcBef>
+                          <a:spcPts val="300"/>
+                        </a:spcBef>
+                        <a:spcAft>
+                          <a:spcPts val="300"/>
+                        </a:spcAft>
+                        <a:buNone/>
+                      </a:pPr>
+                      <a:r>
+                        <a:rPr lang="lt-LT" sz="3600" kern="1200" dirty="0">
+                          <a:solidFill>
+                            <a:schemeClr val="dk1"/>
+                          </a:solidFill>
+                          <a:effectLst/>
+                          <a:latin typeface="+mn-lt"/>
+                          <a:ea typeface="+mn-ea"/>
+                          <a:cs typeface="+mn-cs"/>
+                        </a:rPr>
+                        <a:t>Vieši skelbimai</a:t>
                       </a:r>
                       <a:endParaRPr lang="en-GB" sz="3600" kern="1200" dirty="0">
                         <a:solidFill>
@@ -6871,7 +7046,46 @@
                           <a:ea typeface="+mn-ea"/>
                           <a:cs typeface="+mn-cs"/>
                         </a:rPr>
-                        <a:t>Nėra</a:t>
+                        <a:t>Vieši ir privatūs skelbimai</a:t>
+                      </a:r>
+                      <a:endParaRPr lang="en-GB" sz="3600" kern="1200" dirty="0">
+                        <a:solidFill>
+                          <a:schemeClr val="dk1"/>
+                        </a:solidFill>
+                        <a:effectLst/>
+                        <a:latin typeface="+mn-lt"/>
+                        <a:ea typeface="+mn-ea"/>
+                        <a:cs typeface="+mn-cs"/>
+                      </a:endParaRPr>
+                    </a:p>
+                  </a:txBody>
+                  <a:tcPr marL="68580" marR="68580" marT="0" marB="0"/>
+                </a:tc>
+                <a:tc>
+                  <a:txBody>
+                    <a:bodyPr/>
+                    <a:lstStyle/>
+                    <a:p>
+                      <a:pPr marL="0" algn="l" defTabSz="1828709" rtl="0" eaLnBrk="1" latinLnBrk="0" hangingPunct="1">
+                        <a:spcBef>
+                          <a:spcPts val="300"/>
+                        </a:spcBef>
+                        <a:spcAft>
+                          <a:spcPts val="300"/>
+                        </a:spcAft>
+                        <a:buNone/>
+                      </a:pPr>
+                      <a:r>
+                        <a:rPr lang="lt-LT" sz="3600" kern="1200" dirty="0">
+                          <a:solidFill>
+                            <a:schemeClr val="dk1"/>
+                          </a:solidFill>
+                          <a:effectLst/>
+                          <a:latin typeface="+mn-lt"/>
+                          <a:ea typeface="+mn-ea"/>
+                          <a:cs typeface="+mn-cs"/>
+                        </a:rPr>
+                        <a:t>Privatūs skelbimai</a:t>
                       </a:r>
                       <a:endParaRPr lang="en-GB" sz="3600" kern="1200" dirty="0">
                         <a:solidFill>
@@ -6888,7 +7102,7 @@
                 </a:tc>
                 <a:extLst>
                   <a:ext uri="{0D108BD9-81ED-4DB2-BD59-A6C34878D82A}">
-                    <a16:rowId xmlns:a16="http://schemas.microsoft.com/office/drawing/2014/main" val="184427955"/>
+                    <a16:rowId xmlns:a16="http://schemas.microsoft.com/office/drawing/2014/main" val="3993849208"/>
                   </a:ext>
                 </a:extLst>
               </a:tr>
@@ -7143,7 +7357,7 @@
                   <a:schemeClr val="tx1"/>
                 </a:solidFill>
               </a:rPr>
-              <a:t>Bendras projekto kodo eilučių skaičius – 12651</a:t>
+              <a:t>Bendras projekto kodo eilučių skaičius – 10372</a:t>
             </a:r>
           </a:p>
         </p:txBody>
@@ -7196,16 +7410,13 @@
                 <a:latin typeface="Times New Roman" panose="02020603050405020304" pitchFamily="18" charset="0"/>
                 <a:ea typeface="Calibri" panose="020F0502020204030204" pitchFamily="34" charset="0"/>
               </a:rPr>
-              <a:t>7</a:t>
-            </a:r>
-            <a:r>
-              <a:rPr lang="lt-LT" sz="4000" noProof="0" dirty="0">
-                <a:effectLst/>
-                <a:latin typeface="Times New Roman" panose="02020603050405020304" pitchFamily="18" charset="0"/>
-                <a:ea typeface="Calibri" panose="020F0502020204030204" pitchFamily="34" charset="0"/>
-              </a:rPr>
-              <a:t>733</a:t>
-            </a:r>
+              <a:t>5359</a:t>
+            </a:r>
+            <a:endParaRPr lang="lt-LT" sz="4000" noProof="0" dirty="0">
+              <a:effectLst/>
+              <a:latin typeface="Times New Roman" panose="02020603050405020304" pitchFamily="18" charset="0"/>
+              <a:ea typeface="Calibri" panose="020F0502020204030204" pitchFamily="34" charset="0"/>
+            </a:endParaRPr>
           </a:p>
           <a:p>
             <a:pPr marL="342900" lvl="0" indent="-342900" algn="just">
@@ -7221,7 +7432,7 @@
                 <a:latin typeface="Times New Roman" panose="02020603050405020304" pitchFamily="18" charset="0"/>
                 <a:ea typeface="Calibri" panose="020F0502020204030204" pitchFamily="34" charset="0"/>
               </a:rPr>
-              <a:t>Serverinės dalies programinio kodo eilučių kiekis: 4918</a:t>
+              <a:t>Serverinės dalies programinio kodo eilučių kiekis: 5013</a:t>
             </a:r>
           </a:p>
           <a:p>
@@ -7262,7 +7473,7 @@
                 <a:latin typeface="Times New Roman" panose="02020603050405020304" pitchFamily="18" charset="0"/>
                 <a:ea typeface="Calibri" panose="020F0502020204030204" pitchFamily="34" charset="0"/>
               </a:rPr>
-              <a:t>čių padengimas vienetų testais serverio dalyje procentais: 76%</a:t>
+              <a:t>čių padengimas vienetų testais serverio dalyje procentais: 78%</a:t>
             </a:r>
           </a:p>
           <a:p>
@@ -7279,8 +7490,20 @@
                 <a:latin typeface="Times New Roman" panose="02020603050405020304" pitchFamily="18" charset="0"/>
                 <a:ea typeface="Calibri" panose="020F0502020204030204" pitchFamily="34" charset="0"/>
               </a:rPr>
-              <a:t>Projekto metu parašytas bendras testų kiekis: 268 </a:t>
-            </a:r>
+              <a:t>Projekto metu parašytas bendras testų kiekis: 2</a:t>
+            </a:r>
+            <a:r>
+              <a:rPr lang="lt-LT" sz="4000" dirty="0">
+                <a:latin typeface="Times New Roman" panose="02020603050405020304" pitchFamily="18" charset="0"/>
+                <a:ea typeface="Calibri" panose="020F0502020204030204" pitchFamily="34" charset="0"/>
+              </a:rPr>
+              <a:t>91</a:t>
+            </a:r>
+            <a:endParaRPr lang="lt-LT" sz="4000" noProof="0" dirty="0">
+              <a:effectLst/>
+              <a:latin typeface="Times New Roman" panose="02020603050405020304" pitchFamily="18" charset="0"/>
+              <a:ea typeface="Calibri" panose="020F0502020204030204" pitchFamily="34" charset="0"/>
+            </a:endParaRPr>
           </a:p>
           <a:p>
             <a:pPr marL="342900" lvl="0" indent="-342900" algn="just">
@@ -8458,7 +8681,7 @@
         </p:nvSpPr>
         <p:spPr>
           <a:xfrm>
-            <a:off x="3783616" y="4243346"/>
+            <a:off x="2691416" y="5391140"/>
             <a:ext cx="17710880" cy="3416320"/>
           </a:xfrm>
           <a:prstGeom prst="rect">
@@ -8523,92 +8746,6 @@
               <a:buChar char="•"/>
             </a:pPr>
             <a:endParaRPr lang="lt-LT" dirty="0"/>
-          </a:p>
-        </p:txBody>
-      </p:sp>
-      <p:sp>
-        <p:nvSpPr>
-          <p:cNvPr id="3" name="TextBox 2">
-            <a:extLst>
-              <a:ext uri="{FF2B5EF4-FFF2-40B4-BE49-F238E27FC236}">
-                <a16:creationId xmlns:a16="http://schemas.microsoft.com/office/drawing/2014/main" id="{ED17524D-8C86-E421-1115-5142FD58BFCE}"/>
-              </a:ext>
-            </a:extLst>
-          </p:cNvPr>
-          <p:cNvSpPr txBox="1"/>
-          <p:nvPr/>
-        </p:nvSpPr>
-        <p:spPr>
-          <a:xfrm>
-            <a:off x="3631216" y="8982589"/>
-            <a:ext cx="17710880" cy="2308324"/>
-          </a:xfrm>
-          <a:prstGeom prst="rect">
-            <a:avLst/>
-          </a:prstGeom>
-          <a:noFill/>
-        </p:spPr>
-        <p:txBody>
-          <a:bodyPr wrap="square" rtlCol="0">
-            <a:spAutoFit/>
-          </a:bodyPr>
-          <a:lstStyle/>
-          <a:p>
-            <a:r>
-              <a:rPr lang="lt-LT" b="1" dirty="0"/>
-              <a:t>Funkciniai reikalavimai -</a:t>
-            </a:r>
-          </a:p>
-          <a:p>
-            <a:pPr marL="742950" indent="-742950">
-              <a:buFont typeface="+mj-lt"/>
-              <a:buAutoNum type="arabicPeriod"/>
-            </a:pPr>
-            <a:r>
-              <a:rPr lang="lt-LT" dirty="0"/>
-              <a:t>Rezervuoti įrangą</a:t>
-            </a:r>
-            <a:r>
-              <a:rPr lang="en-GB" dirty="0"/>
-              <a:t>,</a:t>
-            </a:r>
-            <a:r>
-              <a:rPr lang="lt-LT" dirty="0"/>
-              <a:t> </a:t>
-            </a:r>
-            <a:r>
-              <a:rPr lang="en-GB" dirty="0" err="1"/>
-              <a:t>nurodytomis</a:t>
-            </a:r>
-            <a:r>
-              <a:rPr lang="en-GB" dirty="0"/>
-              <a:t> </a:t>
-            </a:r>
-            <a:r>
-              <a:rPr lang="en-GB" dirty="0" err="1"/>
-              <a:t>dienomis</a:t>
-            </a:r>
-            <a:endParaRPr lang="lt-LT" dirty="0"/>
-          </a:p>
-          <a:p>
-            <a:pPr marL="742950" indent="-742950">
-              <a:buFont typeface="+mj-lt"/>
-              <a:buAutoNum type="arabicPeriod"/>
-            </a:pPr>
-            <a:r>
-              <a:rPr lang="lt-LT" dirty="0"/>
-              <a:t>Pokalbių galimybė tarp vartotojų</a:t>
-            </a:r>
-          </a:p>
-          <a:p>
-            <a:pPr marL="742950" indent="-742950">
-              <a:buFont typeface="+mj-lt"/>
-              <a:buAutoNum type="arabicPeriod"/>
-            </a:pPr>
-            <a:r>
-              <a:rPr lang="lt-LT" dirty="0"/>
-              <a:t>Galimybė užsiregistruoti išoriniais tapatybės tiekėjais (Google,Facebook,Microsoft)</a:t>
-            </a:r>
           </a:p>
         </p:txBody>
       </p:sp>

</xml_diff>